<commit_message>
updated for changes done for missed commit files
</commit_message>
<xml_diff>
--- a/Axis_Bank_Statement_Analysis.pptx
+++ b/Axis_Bank_Statement_Analysis.pptx
@@ -10,17 +10,16 @@
     <p:sldId id="258" r:id="rId4"/>
     <p:sldId id="259" r:id="rId5"/>
     <p:sldId id="269" r:id="rId6"/>
-    <p:sldId id="260" r:id="rId7"/>
-    <p:sldId id="270" r:id="rId8"/>
-    <p:sldId id="261" r:id="rId9"/>
-    <p:sldId id="262" r:id="rId10"/>
-    <p:sldId id="271" r:id="rId11"/>
-    <p:sldId id="268" r:id="rId12"/>
-    <p:sldId id="263" r:id="rId13"/>
-    <p:sldId id="264" r:id="rId14"/>
-    <p:sldId id="265" r:id="rId15"/>
-    <p:sldId id="266" r:id="rId16"/>
-    <p:sldId id="267" r:id="rId17"/>
+    <p:sldId id="270" r:id="rId7"/>
+    <p:sldId id="261" r:id="rId8"/>
+    <p:sldId id="262" r:id="rId9"/>
+    <p:sldId id="271" r:id="rId10"/>
+    <p:sldId id="268" r:id="rId11"/>
+    <p:sldId id="263" r:id="rId12"/>
+    <p:sldId id="264" r:id="rId13"/>
+    <p:sldId id="265" r:id="rId14"/>
+    <p:sldId id="266" r:id="rId15"/>
+    <p:sldId id="267" r:id="rId16"/>
   </p:sldIdLst>
   <p:sldSz cx="9144000" cy="6858000" type="screen4x3"/>
   <p:notesSz cx="6858000" cy="9144000"/>
@@ -3255,144 +3254,6 @@
         </p:nvSpPr>
         <p:spPr/>
         <p:txBody>
-          <a:bodyPr/>
-          <a:lstStyle/>
-          <a:p>
-            <a:r>
-              <a:rPr lang="en-IN" dirty="0"/>
-              <a:t>Technologies Used</a:t>
-            </a:r>
-          </a:p>
-        </p:txBody>
-      </p:sp>
-      <p:sp>
-        <p:nvSpPr>
-          <p:cNvPr id="3" name="Content Placeholder 2"/>
-          <p:cNvSpPr>
-            <a:spLocks noGrp="1"/>
-          </p:cNvSpPr>
-          <p:nvPr>
-            <p:ph idx="1"/>
-          </p:nvPr>
-        </p:nvSpPr>
-        <p:spPr>
-          <a:xfrm>
-            <a:off x="983672" y="1600200"/>
-            <a:ext cx="5943601" cy="5105400"/>
-          </a:xfrm>
-        </p:spPr>
-        <p:txBody>
-          <a:bodyPr>
-            <a:normAutofit/>
-          </a:bodyPr>
-          <a:lstStyle/>
-          <a:p>
-            <a:r>
-              <a:rPr lang="en-IN" dirty="0" smtClean="0"/>
-              <a:t>Python</a:t>
-            </a:r>
-          </a:p>
-          <a:p>
-            <a:r>
-              <a:rPr lang="en-IN" dirty="0" smtClean="0"/>
-              <a:t>Pandas </a:t>
-            </a:r>
-          </a:p>
-          <a:p>
-            <a:r>
-              <a:rPr lang="en-IN" dirty="0" err="1" smtClean="0"/>
-              <a:t>Matplotlib</a:t>
-            </a:r>
-            <a:r>
-              <a:rPr lang="en-IN" dirty="0" smtClean="0"/>
-              <a:t> </a:t>
-            </a:r>
-          </a:p>
-          <a:p>
-            <a:r>
-              <a:rPr lang="en-IN" dirty="0" err="1" smtClean="0"/>
-              <a:t>Seaborn</a:t>
-            </a:r>
-            <a:endParaRPr lang="en-IN" dirty="0" smtClean="0"/>
-          </a:p>
-          <a:p>
-            <a:r>
-              <a:rPr lang="en-IN" dirty="0" err="1" smtClean="0"/>
-              <a:t>Plotly</a:t>
-            </a:r>
-            <a:endParaRPr lang="en-IN" dirty="0"/>
-          </a:p>
-          <a:p>
-            <a:r>
-              <a:rPr lang="en-IN" dirty="0"/>
-              <a:t>PostgreSQL</a:t>
-            </a:r>
-          </a:p>
-          <a:p>
-            <a:r>
-              <a:rPr lang="en-IN" dirty="0"/>
-              <a:t>AWS (S3, Lambda, RDS)</a:t>
-            </a:r>
-          </a:p>
-          <a:p>
-            <a:r>
-              <a:rPr lang="en-IN" dirty="0" err="1"/>
-              <a:t>Streamlit</a:t>
-            </a:r>
-            <a:r>
-              <a:rPr lang="en-IN" dirty="0"/>
-              <a:t> </a:t>
-            </a:r>
-            <a:r>
-              <a:rPr lang="en-IN" dirty="0" smtClean="0"/>
-              <a:t>Dashboard</a:t>
-            </a:r>
-            <a:endParaRPr lang="en-IN" dirty="0"/>
-          </a:p>
-        </p:txBody>
-      </p:sp>
-    </p:spTree>
-    <p:extLst>
-      <p:ext uri="{BB962C8B-B14F-4D97-AF65-F5344CB8AC3E}">
-        <p14:creationId xmlns:p14="http://schemas.microsoft.com/office/powerpoint/2010/main" val="1803007376"/>
-      </p:ext>
-    </p:extLst>
-  </p:cSld>
-  <p:clrMapOvr>
-    <a:masterClrMapping/>
-  </p:clrMapOvr>
-</p:sld>
-</file>
-
-<file path=ppt/slides/slide11.xml><?xml version="1.0" encoding="utf-8"?>
-<p:sld xmlns:a="http://schemas.openxmlformats.org/drawingml/2006/main" xmlns:r="http://schemas.openxmlformats.org/officeDocument/2006/relationships" xmlns:p="http://schemas.openxmlformats.org/presentationml/2006/main">
-  <p:cSld>
-    <p:spTree>
-      <p:nvGrpSpPr>
-        <p:cNvPr id="1" name=""/>
-        <p:cNvGrpSpPr/>
-        <p:nvPr/>
-      </p:nvGrpSpPr>
-      <p:grpSpPr>
-        <a:xfrm>
-          <a:off x="0" y="0"/>
-          <a:ext cx="0" cy="0"/>
-          <a:chOff x="0" y="0"/>
-          <a:chExt cx="0" cy="0"/>
-        </a:xfrm>
-      </p:grpSpPr>
-      <p:sp>
-        <p:nvSpPr>
-          <p:cNvPr id="2" name="Title 1"/>
-          <p:cNvSpPr>
-            <a:spLocks noGrp="1"/>
-          </p:cNvSpPr>
-          <p:nvPr>
-            <p:ph type="title"/>
-          </p:nvPr>
-        </p:nvSpPr>
-        <p:spPr/>
-        <p:txBody>
           <a:bodyPr>
             <a:normAutofit fontScale="90000"/>
           </a:bodyPr>
@@ -3445,7 +3306,7 @@
 </p:sld>
 </file>
 
-<file path=ppt/slides/slide12.xml><?xml version="1.0" encoding="utf-8"?>
+<file path=ppt/slides/slide11.xml><?xml version="1.0" encoding="utf-8"?>
 <p:sld xmlns:a="http://schemas.openxmlformats.org/drawingml/2006/main" xmlns:r="http://schemas.openxmlformats.org/officeDocument/2006/relationships" xmlns:p="http://schemas.openxmlformats.org/presentationml/2006/main">
   <p:cSld>
     <p:spTree>
@@ -3516,7 +3377,7 @@
 </p:sld>
 </file>
 
-<file path=ppt/slides/slide13.xml><?xml version="1.0" encoding="utf-8"?>
+<file path=ppt/slides/slide12.xml><?xml version="1.0" encoding="utf-8"?>
 <p:sld xmlns:a="http://schemas.openxmlformats.org/drawingml/2006/main" xmlns:r="http://schemas.openxmlformats.org/officeDocument/2006/relationships" xmlns:p="http://schemas.openxmlformats.org/presentationml/2006/main">
   <p:cSld>
     <p:spTree>
@@ -3587,6 +3448,136 @@
 </p:sld>
 </file>
 
+<file path=ppt/slides/slide13.xml><?xml version="1.0" encoding="utf-8"?>
+<p:sld xmlns:a="http://schemas.openxmlformats.org/drawingml/2006/main" xmlns:r="http://schemas.openxmlformats.org/officeDocument/2006/relationships" xmlns:p="http://schemas.openxmlformats.org/presentationml/2006/main">
+  <p:cSld>
+    <p:spTree>
+      <p:nvGrpSpPr>
+        <p:cNvPr id="1" name=""/>
+        <p:cNvGrpSpPr/>
+        <p:nvPr/>
+      </p:nvGrpSpPr>
+      <p:grpSpPr>
+        <a:xfrm>
+          <a:off x="0" y="0"/>
+          <a:ext cx="0" cy="0"/>
+          <a:chOff x="0" y="0"/>
+          <a:chExt cx="0" cy="0"/>
+        </a:xfrm>
+      </p:grpSpPr>
+      <p:sp>
+        <p:nvSpPr>
+          <p:cNvPr id="2" name="Title 1"/>
+          <p:cNvSpPr>
+            <a:spLocks noGrp="1"/>
+          </p:cNvSpPr>
+          <p:nvPr>
+            <p:ph type="title"/>
+          </p:nvPr>
+        </p:nvSpPr>
+        <p:spPr/>
+        <p:txBody>
+          <a:bodyPr/>
+          <a:lstStyle/>
+          <a:p>
+            <a:r>
+              <a:t>Insights</a:t>
+            </a:r>
+          </a:p>
+        </p:txBody>
+      </p:sp>
+      <p:sp>
+        <p:nvSpPr>
+          <p:cNvPr id="3" name="Content Placeholder 2"/>
+          <p:cNvSpPr>
+            <a:spLocks noGrp="1"/>
+          </p:cNvSpPr>
+          <p:nvPr>
+            <p:ph idx="1"/>
+          </p:nvPr>
+        </p:nvSpPr>
+        <p:spPr/>
+        <p:txBody>
+          <a:bodyPr/>
+          <a:lstStyle/>
+          <a:p>
+            <a:pPr marL="0" indent="0">
+              <a:buNone/>
+            </a:pPr>
+            <a:r>
+              <a:rPr dirty="0"/>
+              <a:t>• High spending months</a:t>
+            </a:r>
+          </a:p>
+          <a:p>
+            <a:pPr marL="0" indent="0">
+              <a:buNone/>
+            </a:pPr>
+            <a:r>
+              <a:rPr dirty="0"/>
+              <a:t>• Low savings</a:t>
+            </a:r>
+          </a:p>
+          <a:p>
+            <a:pPr marL="0" indent="0">
+              <a:buNone/>
+            </a:pPr>
+            <a:r>
+              <a:rPr dirty="0"/>
+              <a:t>• Risk </a:t>
+            </a:r>
+            <a:r>
+              <a:rPr dirty="0" smtClean="0"/>
+              <a:t>indicators</a:t>
+            </a:r>
+            <a:endParaRPr lang="en-US" dirty="0"/>
+          </a:p>
+          <a:p>
+            <a:pPr marL="0" indent="0">
+              <a:buNone/>
+            </a:pPr>
+            <a:r>
+              <a:rPr lang="en-IN" dirty="0"/>
+              <a:t>• </a:t>
+            </a:r>
+            <a:r>
+              <a:rPr lang="en-US" dirty="0" smtClean="0"/>
+              <a:t>Increasing </a:t>
+            </a:r>
+            <a:r>
+              <a:rPr lang="en-US" dirty="0"/>
+              <a:t>transaction trend over time</a:t>
+            </a:r>
+          </a:p>
+          <a:p>
+            <a:pPr marL="0" indent="0">
+              <a:buNone/>
+            </a:pPr>
+            <a:r>
+              <a:rPr lang="en-US" dirty="0"/>
+              <a:t>• Deposits &amp; withdrawals closely aligned</a:t>
+            </a:r>
+          </a:p>
+          <a:p>
+            <a:pPr marL="0" indent="0">
+              <a:buNone/>
+            </a:pPr>
+            <a:r>
+              <a:rPr lang="en-US" dirty="0"/>
+              <a:t>• Sudden drop may indicate anomaly or missing data</a:t>
+            </a:r>
+            <a:endParaRPr dirty="0"/>
+          </a:p>
+        </p:txBody>
+      </p:sp>
+    </p:spTree>
+  </p:cSld>
+  <p:clrMapOvr>
+    <a:masterClrMapping/>
+  </p:clrMapOvr>
+</p:sld>
+</file>
+
 <file path=ppt/slides/slide14.xml><?xml version="1.0" encoding="utf-8"?>
 <p:sld xmlns:a="http://schemas.openxmlformats.org/drawingml/2006/main" xmlns:r="http://schemas.openxmlformats.org/officeDocument/2006/relationships" xmlns:p="http://schemas.openxmlformats.org/presentationml/2006/main">
   <p:cSld>
@@ -3620,7 +3611,7 @@
           <a:lstStyle/>
           <a:p>
             <a:r>
-              <a:t>Insights</a:t>
+              <a:t>Use Cases</a:t>
             </a:r>
           </a:p>
         </p:txBody>
@@ -3640,70 +3631,43 @@
           <a:bodyPr/>
           <a:lstStyle/>
           <a:p>
-            <a:pPr marL="0" indent="0">
-              <a:buNone/>
-            </a:pPr>
             <a:r>
               <a:rPr dirty="0"/>
-              <a:t>• High spending months</a:t>
-            </a:r>
-          </a:p>
-          <a:p>
-            <a:pPr marL="0" indent="0">
-              <a:buNone/>
-            </a:pPr>
-            <a:r>
-              <a:rPr dirty="0"/>
-              <a:t>• Low savings</a:t>
-            </a:r>
-          </a:p>
-          <a:p>
-            <a:pPr marL="0" indent="0">
-              <a:buNone/>
-            </a:pPr>
-            <a:r>
-              <a:rPr dirty="0"/>
-              <a:t>• Risk </a:t>
+              <a:t>Loan </a:t>
             </a:r>
             <a:r>
               <a:rPr dirty="0" smtClean="0"/>
-              <a:t>indicators</a:t>
-            </a:r>
-            <a:endParaRPr lang="en-US" dirty="0"/>
-          </a:p>
-          <a:p>
-            <a:pPr marL="0" indent="0">
-              <a:buNone/>
-            </a:pPr>
-            <a:r>
-              <a:rPr lang="en-IN" dirty="0"/>
-              <a:t>• </a:t>
-            </a:r>
+              <a:t>approval</a:t>
+            </a:r>
+            <a:endParaRPr lang="en-US" dirty="0" smtClean="0"/>
+          </a:p>
+          <a:p>
+            <a:r>
+              <a:rPr lang="en-US" dirty="0"/>
+              <a:t>C</a:t>
+            </a:r>
+            <a:r>
+              <a:rPr dirty="0" smtClean="0"/>
+              <a:t>redit scoring </a:t>
+            </a:r>
+            <a:endParaRPr lang="en-US" dirty="0" smtClean="0"/>
+          </a:p>
+          <a:p>
             <a:r>
               <a:rPr lang="en-US" dirty="0" smtClean="0"/>
-              <a:t>Increasing </a:t>
-            </a:r>
-            <a:r>
-              <a:rPr lang="en-US" dirty="0"/>
-              <a:t>transaction trend over time</a:t>
-            </a:r>
-          </a:p>
-          <a:p>
-            <a:pPr marL="0" indent="0">
-              <a:buNone/>
-            </a:pPr>
-            <a:r>
-              <a:rPr lang="en-US" dirty="0"/>
-              <a:t>• Deposits &amp; withdrawals closely aligned</a:t>
-            </a:r>
-          </a:p>
-          <a:p>
-            <a:pPr marL="0" indent="0">
-              <a:buNone/>
-            </a:pPr>
-            <a:r>
-              <a:rPr lang="en-US" dirty="0"/>
-              <a:t>• Sudden drop may indicate anomaly or missing data</a:t>
+              <a:t>P</a:t>
+            </a:r>
+            <a:r>
+              <a:rPr dirty="0" smtClean="0"/>
+              <a:t>ersonal finance</a:t>
+            </a:r>
+            <a:r>
+              <a:rPr lang="en-US" dirty="0" smtClean="0"/>
+              <a:t> monitoring for Income </a:t>
+            </a:r>
+            <a:r>
+              <a:rPr lang="en-US" smtClean="0"/>
+              <a:t>&amp; Expense</a:t>
             </a:r>
             <a:endParaRPr dirty="0"/>
           </a:p>
@@ -3718,113 +3682,6 @@
 </file>
 
 <file path=ppt/slides/slide15.xml><?xml version="1.0" encoding="utf-8"?>
-<p:sld xmlns:a="http://schemas.openxmlformats.org/drawingml/2006/main" xmlns:r="http://schemas.openxmlformats.org/officeDocument/2006/relationships" xmlns:p="http://schemas.openxmlformats.org/presentationml/2006/main">
-  <p:cSld>
-    <p:spTree>
-      <p:nvGrpSpPr>
-        <p:cNvPr id="1" name=""/>
-        <p:cNvGrpSpPr/>
-        <p:nvPr/>
-      </p:nvGrpSpPr>
-      <p:grpSpPr>
-        <a:xfrm>
-          <a:off x="0" y="0"/>
-          <a:ext cx="0" cy="0"/>
-          <a:chOff x="0" y="0"/>
-          <a:chExt cx="0" cy="0"/>
-        </a:xfrm>
-      </p:grpSpPr>
-      <p:sp>
-        <p:nvSpPr>
-          <p:cNvPr id="2" name="Title 1"/>
-          <p:cNvSpPr>
-            <a:spLocks noGrp="1"/>
-          </p:cNvSpPr>
-          <p:nvPr>
-            <p:ph type="title"/>
-          </p:nvPr>
-        </p:nvSpPr>
-        <p:spPr/>
-        <p:txBody>
-          <a:bodyPr/>
-          <a:lstStyle/>
-          <a:p>
-            <a:r>
-              <a:t>Use Cases</a:t>
-            </a:r>
-          </a:p>
-        </p:txBody>
-      </p:sp>
-      <p:sp>
-        <p:nvSpPr>
-          <p:cNvPr id="3" name="Content Placeholder 2"/>
-          <p:cNvSpPr>
-            <a:spLocks noGrp="1"/>
-          </p:cNvSpPr>
-          <p:nvPr>
-            <p:ph idx="1"/>
-          </p:nvPr>
-        </p:nvSpPr>
-        <p:spPr/>
-        <p:txBody>
-          <a:bodyPr/>
-          <a:lstStyle/>
-          <a:p>
-            <a:r>
-              <a:rPr dirty="0"/>
-              <a:t>Loan </a:t>
-            </a:r>
-            <a:r>
-              <a:rPr dirty="0" smtClean="0"/>
-              <a:t>approval</a:t>
-            </a:r>
-            <a:endParaRPr lang="en-US" dirty="0" smtClean="0"/>
-          </a:p>
-          <a:p>
-            <a:r>
-              <a:rPr lang="en-US" dirty="0"/>
-              <a:t>C</a:t>
-            </a:r>
-            <a:r>
-              <a:rPr dirty="0" smtClean="0"/>
-              <a:t>redit scoring </a:t>
-            </a:r>
-            <a:endParaRPr lang="en-US" dirty="0" smtClean="0"/>
-          </a:p>
-          <a:p>
-            <a:r>
-              <a:rPr lang="en-US" dirty="0" smtClean="0"/>
-              <a:t>P</a:t>
-            </a:r>
-            <a:r>
-              <a:rPr dirty="0" smtClean="0"/>
-              <a:t>ersonal </a:t>
-            </a:r>
-            <a:r>
-              <a:rPr dirty="0" smtClean="0"/>
-              <a:t>finance</a:t>
-            </a:r>
-            <a:r>
-              <a:rPr lang="en-US" dirty="0" smtClean="0"/>
-              <a:t> monitoring for Income </a:t>
-            </a:r>
-            <a:r>
-              <a:rPr lang="en-US" smtClean="0"/>
-              <a:t>&amp; Expense</a:t>
-            </a:r>
-            <a:endParaRPr dirty="0"/>
-          </a:p>
-        </p:txBody>
-      </p:sp>
-    </p:spTree>
-  </p:cSld>
-  <p:clrMapOvr>
-    <a:masterClrMapping/>
-  </p:clrMapOvr>
-</p:sld>
-</file>
-
-<file path=ppt/slides/slide16.xml><?xml version="1.0" encoding="utf-8"?>
 <p:sld xmlns:a="http://schemas.openxmlformats.org/drawingml/2006/main" xmlns:r="http://schemas.openxmlformats.org/officeDocument/2006/relationships" xmlns:p="http://schemas.openxmlformats.org/presentationml/2006/main">
   <p:cSld>
     <p:spTree>
@@ -4330,8 +4187,8 @@
           <a:lstStyle/>
           <a:p>
             <a:r>
-              <a:rPr dirty="0"/>
-              <a:t>Preprocessing</a:t>
+              <a:rPr lang="en-IN" dirty="0"/>
+              <a:t>ETL Pipeline</a:t>
             </a:r>
           </a:p>
         </p:txBody>
@@ -4351,42 +4208,36 @@
           <a:bodyPr/>
           <a:lstStyle/>
           <a:p>
-            <a:pPr marL="0" indent="0">
-              <a:buNone/>
-            </a:pPr>
+            <a:r>
+              <a:rPr lang="en-US" dirty="0"/>
+              <a:t>Extract: Upload &amp; read data</a:t>
+            </a:r>
+          </a:p>
+          <a:p>
+            <a:r>
+              <a:rPr lang="en-US" dirty="0"/>
+              <a:t>Transform: Clean &amp; feature engineering</a:t>
+            </a:r>
+          </a:p>
+          <a:p>
+            <a:r>
+              <a:rPr lang="en-US" dirty="0"/>
+              <a:t>Load: Store in </a:t>
+            </a:r>
             <a:r>
               <a:rPr lang="en-US" dirty="0" smtClean="0"/>
-              <a:t>• </a:t>
-            </a:r>
-            <a:r>
-              <a:rPr lang="en-US" dirty="0"/>
-              <a:t>Handling missing values</a:t>
-            </a:r>
-          </a:p>
-          <a:p>
-            <a:pPr marL="0" indent="0">
-              <a:buNone/>
-            </a:pPr>
-            <a:r>
-              <a:rPr lang="en-US" dirty="0"/>
-              <a:t>• Cleaning text</a:t>
-            </a:r>
-          </a:p>
-          <a:p>
-            <a:pPr marL="0" indent="0">
-              <a:buNone/>
-            </a:pPr>
-            <a:r>
-              <a:rPr lang="en-US" dirty="0"/>
-              <a:t>• Categorizing transactions</a:t>
-            </a:r>
-          </a:p>
-          <a:p>
-            <a:endParaRPr dirty="0"/>
+              <a:t>database</a:t>
+            </a:r>
+            <a:endParaRPr lang="en-US" dirty="0"/>
           </a:p>
         </p:txBody>
       </p:sp>
     </p:spTree>
+    <p:extLst>
+      <p:ext uri="{BB962C8B-B14F-4D97-AF65-F5344CB8AC3E}">
+        <p14:creationId xmlns:p14="http://schemas.microsoft.com/office/powerpoint/2010/main" val="214636803"/>
+      </p:ext>
+    </p:extLst>
   </p:cSld>
   <p:clrMapOvr>
     <a:masterClrMapping/>
@@ -4427,8 +4278,7 @@
           <a:lstStyle/>
           <a:p>
             <a:r>
-              <a:rPr lang="en-IN" dirty="0"/>
-              <a:t>ETL Pipeline</a:t>
+              <a:t>Feature Engineering</a:t>
             </a:r>
           </a:p>
         </p:txBody>
@@ -4448,36 +4298,52 @@
           <a:bodyPr/>
           <a:lstStyle/>
           <a:p>
+            <a:pPr marL="0" indent="0">
+              <a:buNone/>
+            </a:pPr>
             <a:r>
               <a:rPr lang="en-US" dirty="0"/>
-              <a:t>Extract: Upload &amp; read data</a:t>
-            </a:r>
-          </a:p>
-          <a:p>
+              <a:t>• Monthly income</a:t>
+            </a:r>
+          </a:p>
+          <a:p>
+            <a:pPr marL="0" indent="0">
+              <a:buNone/>
+            </a:pPr>
             <a:r>
               <a:rPr lang="en-US" dirty="0"/>
-              <a:t>Transform: Clean &amp; feature engineering</a:t>
-            </a:r>
-          </a:p>
-          <a:p>
+              <a:t>• Monthly expenses</a:t>
+            </a:r>
+          </a:p>
+          <a:p>
+            <a:pPr marL="0" indent="0">
+              <a:buNone/>
+            </a:pPr>
             <a:r>
               <a:rPr lang="en-US" dirty="0"/>
-              <a:t>Load: Store in </a:t>
+              <a:t>• Credit/Debit ratio</a:t>
+            </a:r>
+          </a:p>
+          <a:p>
+            <a:pPr marL="0" indent="0">
+              <a:buNone/>
+            </a:pPr>
+            <a:r>
+              <a:rPr lang="en-US" dirty="0"/>
+              <a:t>• </a:t>
             </a:r>
             <a:r>
               <a:rPr lang="en-US" dirty="0" smtClean="0"/>
-              <a:t>database</a:t>
-            </a:r>
-            <a:endParaRPr lang="en-US" dirty="0"/>
+              <a:t>Average </a:t>
+            </a:r>
+            <a:r>
+              <a:rPr lang="en-US" dirty="0"/>
+              <a:t>balance</a:t>
+            </a:r>
           </a:p>
         </p:txBody>
       </p:sp>
     </p:spTree>
-    <p:extLst>
-      <p:ext uri="{BB962C8B-B14F-4D97-AF65-F5344CB8AC3E}">
-        <p14:creationId xmlns:p14="http://schemas.microsoft.com/office/powerpoint/2010/main" val="214636803"/>
-      </p:ext>
-    </p:extLst>
   </p:cSld>
   <p:clrMapOvr>
     <a:masterClrMapping/>
@@ -4518,7 +4384,7 @@
           <a:lstStyle/>
           <a:p>
             <a:r>
-              <a:t>Feature Engineering</a:t>
+              <a:t>Key Metric</a:t>
             </a:r>
           </a:p>
         </p:txBody>
@@ -4538,47 +4404,15 @@
           <a:bodyPr/>
           <a:lstStyle/>
           <a:p>
-            <a:pPr marL="0" indent="0">
-              <a:buNone/>
-            </a:pPr>
-            <a:r>
-              <a:rPr lang="en-US" dirty="0"/>
-              <a:t>• Monthly income</a:t>
-            </a:r>
-          </a:p>
-          <a:p>
-            <a:pPr marL="0" indent="0">
-              <a:buNone/>
-            </a:pPr>
-            <a:r>
-              <a:rPr lang="en-US" dirty="0"/>
-              <a:t>• Monthly expenses</a:t>
-            </a:r>
-          </a:p>
-          <a:p>
-            <a:pPr marL="0" indent="0">
-              <a:buNone/>
-            </a:pPr>
-            <a:r>
-              <a:rPr lang="en-US" dirty="0"/>
-              <a:t>• Credit/Debit ratio</a:t>
-            </a:r>
-          </a:p>
-          <a:p>
-            <a:pPr marL="0" indent="0">
-              <a:buNone/>
-            </a:pPr>
-            <a:r>
-              <a:rPr lang="en-US" dirty="0"/>
-              <a:t>• </a:t>
-            </a:r>
-            <a:r>
-              <a:rPr lang="en-US" dirty="0" smtClean="0"/>
-              <a:t>Average </a:t>
-            </a:r>
-            <a:r>
-              <a:rPr lang="en-US" dirty="0"/>
-              <a:t>balance</a:t>
+            <a:r>
+              <a:rPr dirty="0"/>
+              <a:t>Credit/Debit Ratio = Credits / Debits</a:t>
+            </a:r>
+          </a:p>
+          <a:p>
+            <a:r>
+              <a:rPr dirty="0"/>
+              <a:t>Indicates financial stability</a:t>
             </a:r>
           </a:p>
         </p:txBody>
@@ -4624,7 +4458,8 @@
           <a:lstStyle/>
           <a:p>
             <a:r>
-              <a:t>Key Metric</a:t>
+              <a:rPr lang="en-IN" dirty="0"/>
+              <a:t>Technologies Used</a:t>
             </a:r>
           </a:p>
         </p:txBody>
@@ -4639,25 +4474,88 @@
             <p:ph idx="1"/>
           </p:nvPr>
         </p:nvSpPr>
-        <p:spPr/>
-        <p:txBody>
-          <a:bodyPr/>
-          <a:lstStyle/>
-          <a:p>
-            <a:r>
-              <a:rPr dirty="0"/>
-              <a:t>Credit/Debit Ratio = Credits / Debits</a:t>
-            </a:r>
-          </a:p>
-          <a:p>
-            <a:r>
-              <a:rPr dirty="0"/>
-              <a:t>Indicates financial stability</a:t>
-            </a:r>
+        <p:spPr>
+          <a:xfrm>
+            <a:off x="983672" y="1600200"/>
+            <a:ext cx="5943601" cy="5105400"/>
+          </a:xfrm>
+        </p:spPr>
+        <p:txBody>
+          <a:bodyPr>
+            <a:normAutofit/>
+          </a:bodyPr>
+          <a:lstStyle/>
+          <a:p>
+            <a:r>
+              <a:rPr lang="en-IN" dirty="0" smtClean="0"/>
+              <a:t>Python</a:t>
+            </a:r>
+          </a:p>
+          <a:p>
+            <a:r>
+              <a:rPr lang="en-IN" dirty="0" smtClean="0"/>
+              <a:t>Pandas </a:t>
+            </a:r>
+          </a:p>
+          <a:p>
+            <a:r>
+              <a:rPr lang="en-IN" dirty="0" err="1" smtClean="0"/>
+              <a:t>Matplotlib</a:t>
+            </a:r>
+            <a:r>
+              <a:rPr lang="en-IN" dirty="0" smtClean="0"/>
+              <a:t> </a:t>
+            </a:r>
+          </a:p>
+          <a:p>
+            <a:r>
+              <a:rPr lang="en-IN" dirty="0" err="1" smtClean="0"/>
+              <a:t>Seaborn</a:t>
+            </a:r>
+            <a:endParaRPr lang="en-IN" dirty="0" smtClean="0"/>
+          </a:p>
+          <a:p>
+            <a:r>
+              <a:rPr lang="en-IN" dirty="0" err="1" smtClean="0"/>
+              <a:t>Plotly</a:t>
+            </a:r>
+            <a:endParaRPr lang="en-IN" dirty="0"/>
+          </a:p>
+          <a:p>
+            <a:r>
+              <a:rPr lang="en-IN" dirty="0"/>
+              <a:t>PostgreSQL</a:t>
+            </a:r>
+          </a:p>
+          <a:p>
+            <a:r>
+              <a:rPr lang="en-IN" dirty="0"/>
+              <a:t>AWS (S3, Lambda, RDS)</a:t>
+            </a:r>
+          </a:p>
+          <a:p>
+            <a:r>
+              <a:rPr lang="en-IN" dirty="0" err="1"/>
+              <a:t>Streamlit</a:t>
+            </a:r>
+            <a:r>
+              <a:rPr lang="en-IN" dirty="0"/>
+              <a:t> </a:t>
+            </a:r>
+            <a:r>
+              <a:rPr lang="en-IN" dirty="0" smtClean="0"/>
+              <a:t>Dashboard</a:t>
+            </a:r>
+            <a:endParaRPr lang="en-IN" dirty="0"/>
           </a:p>
         </p:txBody>
       </p:sp>
     </p:spTree>
+    <p:extLst>
+      <p:ext uri="{BB962C8B-B14F-4D97-AF65-F5344CB8AC3E}">
+        <p14:creationId xmlns:p14="http://schemas.microsoft.com/office/powerpoint/2010/main" val="1803007376"/>
+      </p:ext>
+    </p:extLst>
   </p:cSld>
   <p:clrMapOvr>
     <a:masterClrMapping/>

</xml_diff>